<commit_message>
Increase typography font sizes across all slides for enhanced clarity and readability
</commit_message>
<xml_diff>
--- a/SIH26053_LiDAR_Mapping_Master_Submission.pptx
+++ b/SIH26053_LiDAR_Mapping_Master_Submission.pptx
@@ -3109,8 +3109,8 @@
         </p:blipFill>
         <p:spPr>
           <a:xfrm>
-            <a:off x="9601200" y="182880"/>
-            <a:ext cx="2103120" cy="902070"/>
+            <a:off x="9601200" y="164592"/>
+            <a:ext cx="2194560" cy="941291"/>
           </a:xfrm>
           <a:prstGeom prst="rect">
             <a:avLst/>
@@ -3125,8 +3125,8 @@
         </p:nvSpPr>
         <p:spPr>
           <a:xfrm>
-            <a:off x="731520" y="320040"/>
-            <a:ext cx="2743200" cy="457200"/>
+            <a:off x="731520" y="274320"/>
+            <a:ext cx="2743200" cy="502920"/>
           </a:xfrm>
           <a:prstGeom prst="rect">
             <a:avLst/>
@@ -3140,7 +3140,7 @@
           <a:lstStyle/>
           <a:p>
             <a:pPr>
-              <a:defRPr sz="1800" b="1">
+              <a:defRPr sz="2000" b="1">
                 <a:solidFill>
                   <a:srgbClr val="005B94"/>
                 </a:solidFill>
@@ -3160,8 +3160,8 @@
         </p:nvSpPr>
         <p:spPr>
           <a:xfrm>
-            <a:off x="3200400" y="274320"/>
-            <a:ext cx="5943600" cy="548640"/>
+            <a:off x="3017520" y="256032"/>
+            <a:ext cx="6309360" cy="594360"/>
           </a:xfrm>
           <a:prstGeom prst="rect">
             <a:avLst/>
@@ -3175,7 +3175,7 @@
           <a:lstStyle/>
           <a:p>
             <a:pPr algn="ctr">
-              <a:defRPr sz="2200" b="1">
+              <a:defRPr sz="2400" b="1">
                 <a:solidFill>
                   <a:srgbClr val="005B94"/>
                 </a:solidFill>
@@ -3195,7 +3195,7 @@
         </p:nvSpPr>
         <p:spPr>
           <a:xfrm>
-            <a:off x="731520" y="1051560"/>
+            <a:off x="731520" y="1005840"/>
             <a:ext cx="10728655" cy="18288"/>
           </a:xfrm>
           <a:prstGeom prst="rect">
@@ -3238,8 +3238,8 @@
         </p:nvSpPr>
         <p:spPr>
           <a:xfrm>
-            <a:off x="731520" y="1234440"/>
-            <a:ext cx="10728655" cy="914400"/>
+            <a:off x="731520" y="1143000"/>
+            <a:ext cx="10728655" cy="960120"/>
           </a:xfrm>
           <a:prstGeom prst="rect">
             <a:avLst/>
@@ -3253,7 +3253,7 @@
           <a:lstStyle/>
           <a:p>
             <a:pPr algn="ctr">
-              <a:defRPr sz="2500" b="1">
+              <a:defRPr sz="2700" b="1">
                 <a:solidFill>
                   <a:srgbClr val="0F172A"/>
                 </a:solidFill>
@@ -3273,8 +3273,8 @@
         </p:nvSpPr>
         <p:spPr>
           <a:xfrm>
-            <a:off x="731520" y="2286000"/>
-            <a:ext cx="7132320" cy="3931920"/>
+            <a:off x="731520" y="2240280"/>
+            <a:ext cx="7315200" cy="4114800"/>
           </a:xfrm>
           <a:prstGeom prst="rect">
             <a:avLst/>
@@ -3289,11 +3289,11 @@
           <a:p>
             <a:pPr>
               <a:spcAft>
-                <a:spcPts val="1000"/>
+                <a:spcPts val="1100"/>
               </a:spcAft>
             </a:pPr>
             <a:r>
-              <a:rPr b="1" sz="1350">
+              <a:rPr b="1" sz="1550">
                 <a:solidFill>
                   <a:srgbClr val="0F172A"/>
                 </a:solidFill>
@@ -3301,7 +3301,7 @@
               <a:t>• Problem Statement ID – </a:t>
             </a:r>
             <a:r>
-              <a:rPr b="0" sz="1350">
+              <a:rPr b="0" sz="1550">
                 <a:solidFill>
                   <a:srgbClr val="005B94"/>
                 </a:solidFill>
@@ -3312,11 +3312,11 @@
           <a:p>
             <a:pPr>
               <a:spcAft>
-                <a:spcPts val="1000"/>
+                <a:spcPts val="1100"/>
               </a:spcAft>
             </a:pPr>
             <a:r>
-              <a:rPr b="1" sz="1350">
+              <a:rPr b="1" sz="1550">
                 <a:solidFill>
                   <a:srgbClr val="0F172A"/>
                 </a:solidFill>
@@ -3324,7 +3324,7 @@
               <a:t>• Problem Statement Title – </a:t>
             </a:r>
             <a:r>
-              <a:rPr b="0" sz="1350">
+              <a:rPr b="0" sz="1550">
                 <a:solidFill>
                   <a:srgbClr val="0F172A"/>
                 </a:solidFill>
@@ -3335,11 +3335,11 @@
           <a:p>
             <a:pPr>
               <a:spcAft>
-                <a:spcPts val="1000"/>
+                <a:spcPts val="1100"/>
               </a:spcAft>
             </a:pPr>
             <a:r>
-              <a:rPr b="1" sz="1350">
+              <a:rPr b="1" sz="1550">
                 <a:solidFill>
                   <a:srgbClr val="0F172A"/>
                 </a:solidFill>
@@ -3347,7 +3347,7 @@
               <a:t>• Ministry / Organization – </a:t>
             </a:r>
             <a:r>
-              <a:rPr b="0" sz="1350">
+              <a:rPr b="0" sz="1550">
                 <a:solidFill>
                   <a:srgbClr val="005B94"/>
                 </a:solidFill>
@@ -3358,11 +3358,11 @@
           <a:p>
             <a:pPr>
               <a:spcAft>
-                <a:spcPts val="1000"/>
+                <a:spcPts val="1100"/>
               </a:spcAft>
             </a:pPr>
             <a:r>
-              <a:rPr b="1" sz="1350">
+              <a:rPr b="1" sz="1550">
                 <a:solidFill>
                   <a:srgbClr val="0F172A"/>
                 </a:solidFill>
@@ -3370,7 +3370,7 @@
               <a:t>• Theme – </a:t>
             </a:r>
             <a:r>
-              <a:rPr b="0" sz="1350">
+              <a:rPr b="0" sz="1550">
                 <a:solidFill>
                   <a:srgbClr val="0F172A"/>
                 </a:solidFill>
@@ -3381,11 +3381,11 @@
           <a:p>
             <a:pPr>
               <a:spcAft>
-                <a:spcPts val="1000"/>
+                <a:spcPts val="1100"/>
               </a:spcAft>
             </a:pPr>
             <a:r>
-              <a:rPr b="1" sz="1350">
+              <a:rPr b="1" sz="1550">
                 <a:solidFill>
                   <a:srgbClr val="0F172A"/>
                 </a:solidFill>
@@ -3393,7 +3393,7 @@
               <a:t>• PS Category – </a:t>
             </a:r>
             <a:r>
-              <a:rPr b="0" sz="1350">
+              <a:rPr b="0" sz="1550">
                 <a:solidFill>
                   <a:srgbClr val="0F172A"/>
                 </a:solidFill>
@@ -3404,11 +3404,11 @@
           <a:p>
             <a:pPr>
               <a:spcAft>
-                <a:spcPts val="1000"/>
+                <a:spcPts val="1100"/>
               </a:spcAft>
             </a:pPr>
             <a:r>
-              <a:rPr b="1" sz="1350">
+              <a:rPr b="1" sz="1550">
                 <a:solidFill>
                   <a:srgbClr val="0F172A"/>
                 </a:solidFill>
@@ -3416,7 +3416,7 @@
               <a:t>• Team Name (Registered on portal) – </a:t>
             </a:r>
             <a:r>
-              <a:rPr b="0" sz="1350">
+              <a:rPr b="0" sz="1550">
                 <a:solidFill>
                   <a:srgbClr val="005B94"/>
                 </a:solidFill>
@@ -3427,11 +3427,11 @@
           <a:p>
             <a:pPr>
               <a:spcAft>
-                <a:spcPts val="1000"/>
+                <a:spcPts val="1100"/>
               </a:spcAft>
             </a:pPr>
             <a:r>
-              <a:rPr b="1" sz="1350">
+              <a:rPr b="1" sz="1550">
                 <a:solidFill>
                   <a:srgbClr val="0F172A"/>
                 </a:solidFill>
@@ -3439,7 +3439,7 @@
               <a:t>• Target System – </a:t>
             </a:r>
             <a:r>
-              <a:rPr b="0" sz="1350">
+              <a:rPr b="0" sz="1550">
                 <a:solidFill>
                   <a:srgbClr val="0F172A"/>
                 </a:solidFill>
@@ -3465,8 +3465,8 @@
         </p:blipFill>
         <p:spPr>
           <a:xfrm>
-            <a:off x="8138160" y="2011680"/>
-            <a:ext cx="3291840" cy="3787502"/>
+            <a:off x="8229600" y="2103120"/>
+            <a:ext cx="3383280" cy="3892710"/>
           </a:xfrm>
           <a:prstGeom prst="rect">
             <a:avLst/>
@@ -3644,7 +3644,7 @@
           <a:lstStyle/>
           <a:p>
             <a:pPr algn="l">
-              <a:defRPr sz="1900" b="1">
+              <a:defRPr sz="2100" b="1">
                 <a:solidFill>
                   <a:srgbClr val="FFFFFF"/>
                 </a:solidFill>
@@ -3688,7 +3688,7 @@
         </p:nvSpPr>
         <p:spPr>
           <a:xfrm>
-            <a:off x="548640" y="841248"/>
+            <a:off x="548640" y="822960"/>
             <a:ext cx="3291840" cy="320040"/>
           </a:xfrm>
           <a:prstGeom prst="rect">
@@ -3703,7 +3703,7 @@
           <a:lstStyle/>
           <a:p>
             <a:pPr>
-              <a:defRPr sz="1600" b="1">
+              <a:defRPr sz="1800" b="1">
                 <a:solidFill>
                   <a:srgbClr val="C2410C"/>
                 </a:solidFill>
@@ -3758,7 +3758,7 @@
           <a:p>
             <a:pPr algn="ctr"/>
             <a:r>
-              <a:rPr b="1" sz="1050">
+              <a:rPr b="1" sz="1200">
                 <a:solidFill>
                   <a:srgbClr val="0F172A"/>
                 </a:solidFill>
@@ -3766,7 +3766,7 @@
               <a:t>Compute Bottleneck: </a:t>
             </a:r>
             <a:r>
-              <a:rPr sz="1000">
+              <a:rPr sz="1100">
                 <a:solidFill>
                   <a:srgbClr val="0F172A"/>
                 </a:solidFill>
@@ -3819,7 +3819,7 @@
           <a:p>
             <a:pPr algn="ctr"/>
             <a:r>
-              <a:rPr b="1" sz="1050">
+              <a:rPr b="1" sz="1200">
                 <a:solidFill>
                   <a:srgbClr val="0F172A"/>
                 </a:solidFill>
@@ -3827,7 +3827,7 @@
               <a:t>2D Blindness: </a:t>
             </a:r>
             <a:r>
-              <a:rPr sz="1000">
+              <a:rPr sz="1100">
                 <a:solidFill>
                   <a:srgbClr val="0F172A"/>
                 </a:solidFill>
@@ -3880,7 +3880,7 @@
           <a:p>
             <a:pPr algn="ctr"/>
             <a:r>
-              <a:rPr b="1" sz="1050">
+              <a:rPr b="1" sz="1200">
                 <a:solidFill>
                   <a:srgbClr val="0F172A"/>
                 </a:solidFill>
@@ -3888,7 +3888,7 @@
               <a:t>Memory Overhead: </a:t>
             </a:r>
             <a:r>
-              <a:rPr sz="1000">
+              <a:rPr sz="1100">
                 <a:solidFill>
                   <a:srgbClr val="0F172A"/>
                 </a:solidFill>
@@ -3941,7 +3941,7 @@
           <a:p>
             <a:pPr algn="ctr"/>
             <a:r>
-              <a:rPr b="1" sz="1050">
+              <a:rPr b="1" sz="1200">
                 <a:solidFill>
                   <a:srgbClr val="0F172A"/>
                 </a:solidFill>
@@ -3949,7 +3949,7 @@
               <a:t>Dynamic Obstacle Smear: </a:t>
             </a:r>
             <a:r>
-              <a:rPr sz="1000">
+              <a:rPr sz="1100">
                 <a:solidFill>
                   <a:srgbClr val="0F172A"/>
                 </a:solidFill>
@@ -3967,7 +3967,7 @@
         </p:nvSpPr>
         <p:spPr>
           <a:xfrm>
-            <a:off x="4023360" y="841248"/>
+            <a:off x="4023360" y="822960"/>
             <a:ext cx="4663440" cy="320040"/>
           </a:xfrm>
           <a:prstGeom prst="rect">
@@ -3982,7 +3982,7 @@
           <a:lstStyle/>
           <a:p>
             <a:pPr>
-              <a:defRPr sz="1600" b="1">
+              <a:defRPr sz="1800" b="1">
                 <a:solidFill>
                   <a:srgbClr val="107846"/>
                 </a:solidFill>
@@ -4011,7 +4011,7 @@
         <p:spPr>
           <a:xfrm>
             <a:off x="4023360" y="1188720"/>
-            <a:ext cx="4663440" cy="3108960"/>
+            <a:ext cx="4663440" cy="3063240"/>
           </a:xfrm>
           <a:prstGeom prst="rect">
             <a:avLst/>
@@ -4026,8 +4026,8 @@
         </p:nvSpPr>
         <p:spPr>
           <a:xfrm>
-            <a:off x="4023360" y="4434840"/>
-            <a:ext cx="4663440" cy="1828800"/>
+            <a:off x="4023360" y="4389120"/>
+            <a:ext cx="4663440" cy="1874519"/>
           </a:xfrm>
           <a:prstGeom prst="roundRect">
             <a:avLst/>
@@ -4056,14 +4056,14 @@
           </a:fontRef>
         </p:style>
         <p:txBody>
-          <a:bodyPr rtlCol="0" anchor="ctr" wrap="square" lIns="137160" rIns="137160" tIns="137160" bIns="137160"/>
+          <a:bodyPr rtlCol="0" anchor="ctr" wrap="square" lIns="128016" rIns="128016" tIns="128016" bIns="128016"/>
           <a:lstStyle/>
           <a:p>
             <a:pPr algn="ctr">
               <a:spcAft>
                 <a:spcPts val="400"/>
               </a:spcAft>
-              <a:defRPr b="1" sz="1200">
+              <a:defRPr b="1" sz="1400">
                 <a:solidFill>
                   <a:srgbClr val="C2410C"/>
                 </a:solidFill>
@@ -4078,7 +4078,7 @@
               <a:spcAft>
                 <a:spcPts val="200"/>
               </a:spcAft>
-              <a:defRPr sz="950">
+              <a:defRPr sz="1100">
                 <a:solidFill>
                   <a:srgbClr val="0F172A"/>
                 </a:solidFill>
@@ -4093,7 +4093,7 @@
               <a:spcAft>
                 <a:spcPts val="200"/>
               </a:spcAft>
-              <a:defRPr sz="950">
+              <a:defRPr sz="1100">
                 <a:solidFill>
                   <a:srgbClr val="0F172A"/>
                 </a:solidFill>
@@ -4108,7 +4108,7 @@
               <a:spcAft>
                 <a:spcPts val="200"/>
               </a:spcAft>
-              <a:defRPr sz="950">
+              <a:defRPr sz="1100">
                 <a:solidFill>
                   <a:srgbClr val="0F172A"/>
                 </a:solidFill>
@@ -4128,7 +4128,7 @@
         </p:nvSpPr>
         <p:spPr>
           <a:xfrm>
-            <a:off x="8869680" y="841248"/>
+            <a:off x="8869680" y="822960"/>
             <a:ext cx="2743200" cy="320040"/>
           </a:xfrm>
           <a:prstGeom prst="rect">
@@ -4143,7 +4143,7 @@
           <a:lstStyle/>
           <a:p>
             <a:pPr>
-              <a:defRPr sz="1600" b="1">
+              <a:defRPr sz="1800" b="1">
                 <a:solidFill>
                   <a:srgbClr val="005B94"/>
                 </a:solidFill>
@@ -4197,7 +4197,7 @@
           <a:lstStyle/>
           <a:p>
             <a:pPr algn="ctr">
-              <a:defRPr b="1" sz="1000">
+              <a:defRPr b="1" sz="1150">
                 <a:solidFill>
                   <a:srgbClr val="005B94"/>
                 </a:solidFill>
@@ -4209,7 +4209,7 @@
           </a:p>
           <a:p>
             <a:pPr>
-              <a:defRPr sz="850">
+              <a:defRPr sz="1000">
                 <a:solidFill>
                   <a:srgbClr val="0F172A"/>
                 </a:solidFill>
@@ -4263,7 +4263,7 @@
           <a:lstStyle/>
           <a:p>
             <a:pPr algn="ctr">
-              <a:defRPr b="1" sz="1000">
+              <a:defRPr b="1" sz="1150">
                 <a:solidFill>
                   <a:srgbClr val="005B94"/>
                 </a:solidFill>
@@ -4275,7 +4275,7 @@
           </a:p>
           <a:p>
             <a:pPr>
-              <a:defRPr sz="850">
+              <a:defRPr sz="1000">
                 <a:solidFill>
                   <a:srgbClr val="0F172A"/>
                 </a:solidFill>
@@ -4329,7 +4329,7 @@
           <a:lstStyle/>
           <a:p>
             <a:pPr algn="ctr">
-              <a:defRPr b="1" sz="1000">
+              <a:defRPr b="1" sz="1150">
                 <a:solidFill>
                   <a:srgbClr val="005B94"/>
                 </a:solidFill>
@@ -4341,7 +4341,7 @@
           </a:p>
           <a:p>
             <a:pPr>
-              <a:defRPr sz="850">
+              <a:defRPr sz="1000">
                 <a:solidFill>
                   <a:srgbClr val="0F172A"/>
                 </a:solidFill>
@@ -4395,7 +4395,7 @@
           <a:lstStyle/>
           <a:p>
             <a:pPr algn="ctr">
-              <a:defRPr b="1" sz="1000">
+              <a:defRPr b="1" sz="1150">
                 <a:solidFill>
                   <a:srgbClr val="005B94"/>
                 </a:solidFill>
@@ -4407,7 +4407,7 @@
           </a:p>
           <a:p>
             <a:pPr>
-              <a:defRPr sz="850">
+              <a:defRPr sz="1000">
                 <a:solidFill>
                   <a:srgbClr val="0F172A"/>
                 </a:solidFill>
@@ -4461,7 +4461,7 @@
           <a:lstStyle/>
           <a:p>
             <a:pPr algn="ctr">
-              <a:defRPr b="1" sz="1000">
+              <a:defRPr b="1" sz="1150">
                 <a:solidFill>
                   <a:srgbClr val="005B94"/>
                 </a:solidFill>
@@ -4473,7 +4473,7 @@
           </a:p>
           <a:p>
             <a:pPr>
-              <a:defRPr sz="850">
+              <a:defRPr sz="1000">
                 <a:solidFill>
                   <a:srgbClr val="0F172A"/>
                 </a:solidFill>
@@ -4527,7 +4527,7 @@
           <a:lstStyle/>
           <a:p>
             <a:pPr algn="ctr">
-              <a:defRPr b="1" sz="1000">
+              <a:defRPr b="1" sz="1150">
                 <a:solidFill>
                   <a:srgbClr val="005B94"/>
                 </a:solidFill>
@@ -4539,7 +4539,7 @@
           </a:p>
           <a:p>
             <a:pPr>
-              <a:defRPr sz="850">
+              <a:defRPr sz="1000">
                 <a:solidFill>
                   <a:srgbClr val="0F172A"/>
                 </a:solidFill>
@@ -4722,7 +4722,7 @@
           <a:lstStyle/>
           <a:p>
             <a:pPr algn="l">
-              <a:defRPr sz="1900" b="1">
+              <a:defRPr sz="2100" b="1">
                 <a:solidFill>
                   <a:srgbClr val="FFFFFF"/>
                 </a:solidFill>
@@ -4774,8 +4774,8 @@
         </p:blipFill>
         <p:spPr>
           <a:xfrm>
-            <a:off x="731520" y="914400"/>
-            <a:ext cx="10698480" cy="3474720"/>
+            <a:off x="731520" y="868680"/>
+            <a:ext cx="10698480" cy="3520440"/>
           </a:xfrm>
           <a:prstGeom prst="rect">
             <a:avLst/>
@@ -4790,8 +4790,8 @@
         </p:nvSpPr>
         <p:spPr>
           <a:xfrm>
-            <a:off x="731520" y="4617720"/>
-            <a:ext cx="2029968" cy="1645920"/>
+            <a:off x="731520" y="4553712"/>
+            <a:ext cx="2029968" cy="1737360"/>
           </a:xfrm>
           <a:prstGeom prst="roundRect">
             <a:avLst/>
@@ -4825,9 +4825,9 @@
           <a:p>
             <a:pPr algn="ctr">
               <a:spcAft>
-                <a:spcPts val="400"/>
+                <a:spcPts val="300"/>
               </a:spcAft>
-              <a:defRPr b="1" sz="1000">
+              <a:defRPr b="1" sz="1200">
                 <a:solidFill>
                   <a:srgbClr val="0F172A"/>
                 </a:solidFill>
@@ -4839,14 +4839,14 @@
           </a:p>
           <a:p>
             <a:pPr>
-              <a:defRPr sz="850">
+              <a:defRPr sz="1050">
                 <a:solidFill>
                   <a:srgbClr val="0F172A"/>
                 </a:solidFill>
               </a:defRPr>
             </a:pPr>
             <a:r>
-              <a:t>Raw 128-beam 3D LiDAR point cloud @ 20Hz. Patchwork++ cylindrical RANSAC isolates ground plane from obstacle inliers in 3.4ms.</a:t>
+              <a:t>Raw 128-beam 3D LiDAR point cloud @ 20Hz. Patchwork++ cylindrical RANSAC isolates ground plane in 3.4ms.</a:t>
             </a:r>
           </a:p>
         </p:txBody>
@@ -4859,8 +4859,8 @@
         </p:nvSpPr>
         <p:spPr>
           <a:xfrm>
-            <a:off x="2898648" y="4617720"/>
-            <a:ext cx="2029968" cy="1645920"/>
+            <a:off x="2898648" y="4553712"/>
+            <a:ext cx="2029968" cy="1737360"/>
           </a:xfrm>
           <a:prstGeom prst="roundRect">
             <a:avLst/>
@@ -4894,9 +4894,9 @@
           <a:p>
             <a:pPr algn="ctr">
               <a:spcAft>
-                <a:spcPts val="400"/>
+                <a:spcPts val="300"/>
               </a:spcAft>
-              <a:defRPr b="1" sz="1000">
+              <a:defRPr b="1" sz="1200">
                 <a:solidFill>
                   <a:srgbClr val="005B94"/>
                 </a:solidFill>
@@ -4908,14 +4908,14 @@
           </a:p>
           <a:p>
             <a:pPr>
-              <a:defRPr sz="850">
+              <a:defRPr sz="1050">
                 <a:solidFill>
                   <a:srgbClr val="0F172A"/>
                 </a:solidFill>
               </a:defRPr>
             </a:pPr>
             <a:r>
-              <a:t>Concentric distance-dependent binning: Zone A (5cm, 0-10m), Zone B (20cm, 10-35m), Zone C (50cm, 35-100m). Slashes memory by &gt;85%.</a:t>
+              <a:t>Concentric distance binning: Zone A (5cm, 0-10m), Zone B (20cm, 10-35m), Zone C (50cm). &gt;85% RAM saved.</a:t>
             </a:r>
           </a:p>
         </p:txBody>
@@ -4928,8 +4928,8 @@
         </p:nvSpPr>
         <p:spPr>
           <a:xfrm>
-            <a:off x="5065776" y="4617720"/>
-            <a:ext cx="2029968" cy="1645920"/>
+            <a:off x="5065776" y="4553712"/>
+            <a:ext cx="2029968" cy="1737360"/>
           </a:xfrm>
           <a:prstGeom prst="roundRect">
             <a:avLst/>
@@ -4963,9 +4963,9 @@
           <a:p>
             <a:pPr algn="ctr">
               <a:spcAft>
-                <a:spcPts val="400"/>
+                <a:spcPts val="300"/>
               </a:spcAft>
-              <a:defRPr b="1" sz="1000">
+              <a:defRPr b="1" sz="1200">
                 <a:solidFill>
                   <a:srgbClr val="0284C7"/>
                 </a:solidFill>
@@ -4977,14 +4977,14 @@
           </a:p>
           <a:p>
             <a:pPr>
-              <a:defRPr sz="850">
+              <a:defRPr sz="1050">
                 <a:solidFill>
                   <a:srgbClr val="0F172A"/>
                 </a:solidFill>
               </a:defRPr>
             </a:pPr>
             <a:r>
-              <a:t>Computes Z_max, Z_min, roughness σ_z², and normal vector n per cell. Directly calculates slope angle and step-climbing traversability.</a:t>
+              <a:t>Stores Z_max, Z_min, roughness σ_z², and normal vector n. Directly determines slope angle and obstacle height.</a:t>
             </a:r>
           </a:p>
         </p:txBody>
@@ -4997,8 +4997,8 @@
         </p:nvSpPr>
         <p:spPr>
           <a:xfrm>
-            <a:off x="7232904" y="4617720"/>
-            <a:ext cx="2029968" cy="1645920"/>
+            <a:off x="7232904" y="4553712"/>
+            <a:ext cx="2029968" cy="1737360"/>
           </a:xfrm>
           <a:prstGeom prst="roundRect">
             <a:avLst/>
@@ -5032,9 +5032,9 @@
           <a:p>
             <a:pPr algn="ctr">
               <a:spcAft>
-                <a:spcPts val="400"/>
+                <a:spcPts val="300"/>
               </a:spcAft>
-              <a:defRPr b="1" sz="1000">
+              <a:defRPr b="1" sz="1200">
                 <a:solidFill>
                   <a:srgbClr val="7C3AED"/>
                 </a:solidFill>
@@ -5046,14 +5046,14 @@
           </a:p>
           <a:p>
             <a:pPr>
-              <a:defRPr sz="850">
+              <a:defRPr sz="1050">
                 <a:solidFill>
                   <a:srgbClr val="0F172A"/>
                 </a:solidFill>
               </a:defRPr>
             </a:pPr>
             <a:r>
-              <a:t>Sparse Polar CNN running TensorRT INT8 quantization. Predicts traversability masks and dynamic obstacles in 14.2ms (&lt;15W SWaP).</a:t>
+              <a:t>Sparse Polar CNN with TensorRT INT8 quantization. Predicts dynamic obstacles and terrain masks in 14.2ms (&lt;15W SWaP).</a:t>
             </a:r>
           </a:p>
         </p:txBody>
@@ -5066,8 +5066,8 @@
         </p:nvSpPr>
         <p:spPr>
           <a:xfrm>
-            <a:off x="9400032" y="4617720"/>
-            <a:ext cx="2029968" cy="1645920"/>
+            <a:off x="9400032" y="4553712"/>
+            <a:ext cx="2029968" cy="1737360"/>
           </a:xfrm>
           <a:prstGeom prst="roundRect">
             <a:avLst/>
@@ -5101,9 +5101,9 @@
           <a:p>
             <a:pPr algn="ctr">
               <a:spcAft>
-                <a:spcPts val="400"/>
+                <a:spcPts val="300"/>
               </a:spcAft>
-              <a:defRPr b="1" sz="1000">
+              <a:defRPr b="1" sz="1200">
                 <a:solidFill>
                   <a:srgbClr val="059669"/>
                 </a:solidFill>
@@ -5115,14 +5115,14 @@
           </a:p>
           <a:p>
             <a:pPr>
-              <a:defRPr sz="850">
+              <a:defRPr sz="1050">
                 <a:solidFill>
                   <a:srgbClr val="0F172A"/>
                 </a:solidFill>
               </a:defRPr>
             </a:pPr>
             <a:r>
-              <a:t>Recursive log-odds evidence update + Kalman filter velocity estimation purges moving ghost trails. Publishes standard /costmap_2d.</a:t>
+              <a:t>Recursive log-odds evidence update + Kalman filter velocity estimation purges ghost trails. Publishes /costmap_2d.</a:t>
             </a:r>
           </a:p>
         </p:txBody>
@@ -5298,7 +5298,7 @@
           <a:lstStyle/>
           <a:p>
             <a:pPr algn="l">
-              <a:defRPr sz="1900" b="1">
+              <a:defRPr sz="2100" b="1">
                 <a:solidFill>
                   <a:srgbClr val="FFFFFF"/>
                 </a:solidFill>
@@ -5379,7 +5379,7 @@
               <a:spcAft>
                 <a:spcPts val="400"/>
               </a:spcAft>
-              <a:defRPr b="1" sz="1200">
+              <a:defRPr b="1" sz="1400">
                 <a:solidFill>
                   <a:srgbClr val="C2410C"/>
                 </a:solidFill>
@@ -5391,7 +5391,7 @@
           </a:p>
           <a:p>
             <a:pPr>
-              <a:defRPr sz="900">
+              <a:defRPr sz="1050">
                 <a:solidFill>
                   <a:srgbClr val="0F172A"/>
                 </a:solidFill>
@@ -5402,11 +5402,11 @@
             </a:r>
             <a:br/>
             <a:r>
-              <a:t>• Open Sensor Compatibility: Plug-and-play with Velodyne, Ouster, Hesai, and RoboSense 16/32/64/128-beam LiDARs.</a:t>
+              <a:t>• Open Sensor Compatibility: Plug-and-play with Velodyne, Ouster, Hesai, and RoboSense LiDARs.</a:t>
             </a:r>
             <a:br/>
             <a:r>
-              <a:t>• Edge-Verified: Validated on NVIDIA Jetson Orin Nano (8GB) and AGX Xavier under 15W power constraints.</a:t>
+              <a:t>• Edge-Verified: Validated on NVIDIA Jetson Orin Nano (8GB) under 15W power constraints.</a:t>
             </a:r>
           </a:p>
         </p:txBody>
@@ -5456,7 +5456,7 @@
               <a:spcAft>
                 <a:spcPts val="400"/>
               </a:spcAft>
-              <a:defRPr b="1" sz="1200">
+              <a:defRPr b="1" sz="1400">
                 <a:solidFill>
                   <a:srgbClr val="C2410C"/>
                 </a:solidFill>
@@ -5468,7 +5468,7 @@
           </a:p>
           <a:p>
             <a:pPr>
-              <a:defRPr sz="900">
+              <a:defRPr sz="1050">
                 <a:solidFill>
                   <a:srgbClr val="0F172A"/>
                 </a:solidFill>
@@ -5479,7 +5479,7 @@
             </a:r>
             <a:br/>
             <a:r>
-              <a:t>• GPS-Denied Autonomous Operation: Tightly coupled with wheel odometry and IMU for subterranean &amp; dense urban missions.</a:t>
+              <a:t>• GPS-Denied Autonomous Operation: Tightly coupled with wheel odometry and IMU.</a:t>
             </a:r>
             <a:br/>
             <a:r>
@@ -5511,7 +5511,7 @@
           <a:lstStyle/>
           <a:p>
             <a:pPr>
-              <a:defRPr b="1" sz="1200">
+              <a:defRPr b="1" sz="1400">
                 <a:solidFill>
                   <a:srgbClr val="005B94"/>
                 </a:solidFill>
@@ -5554,7 +5554,7 @@
                     <a:lstStyle/>
                     <a:p>
                       <a:pPr>
-                        <a:defRPr b="1" sz="900">
+                        <a:defRPr b="1" sz="1050">
                           <a:solidFill>
                             <a:srgbClr val="FFFFFF"/>
                           </a:solidFill>
@@ -5577,7 +5577,7 @@
                     <a:lstStyle/>
                     <a:p>
                       <a:pPr>
-                        <a:defRPr b="1" sz="900">
+                        <a:defRPr b="1" sz="1050">
                           <a:solidFill>
                             <a:srgbClr val="FFFFFF"/>
                           </a:solidFill>
@@ -5600,7 +5600,7 @@
                     <a:lstStyle/>
                     <a:p>
                       <a:pPr>
-                        <a:defRPr b="1" sz="900">
+                        <a:defRPr b="1" sz="1050">
                           <a:solidFill>
                             <a:srgbClr val="FFFFFF"/>
                           </a:solidFill>
@@ -5623,7 +5623,7 @@
                     <a:lstStyle/>
                     <a:p>
                       <a:pPr>
-                        <a:defRPr b="1" sz="900">
+                        <a:defRPr b="1" sz="1050">
                           <a:solidFill>
                             <a:srgbClr val="FFFFFF"/>
                           </a:solidFill>
@@ -5648,7 +5648,7 @@
                     <a:lstStyle/>
                     <a:p>
                       <a:pPr>
-                        <a:defRPr sz="850">
+                        <a:defRPr sz="1000">
                           <a:solidFill>
                             <a:srgbClr val="0F172A"/>
                           </a:solidFill>
@@ -5667,7 +5667,7 @@
                     <a:lstStyle/>
                     <a:p>
                       <a:pPr>
-                        <a:defRPr sz="850">
+                        <a:defRPr sz="1000">
                           <a:solidFill>
                             <a:srgbClr val="0F172A"/>
                           </a:solidFill>
@@ -5686,7 +5686,7 @@
                     <a:lstStyle/>
                     <a:p>
                       <a:pPr>
-                        <a:defRPr sz="850">
+                        <a:defRPr sz="1000">
                           <a:solidFill>
                             <a:srgbClr val="0F172A"/>
                           </a:solidFill>
@@ -5705,7 +5705,7 @@
                     <a:lstStyle/>
                     <a:p>
                       <a:pPr>
-                        <a:defRPr sz="850" b="1">
+                        <a:defRPr sz="1000" b="1">
                           <a:solidFill>
                             <a:srgbClr val="107846"/>
                           </a:solidFill>
@@ -5730,7 +5730,7 @@
                     <a:lstStyle/>
                     <a:p>
                       <a:pPr>
-                        <a:defRPr sz="850">
+                        <a:defRPr sz="1000">
                           <a:solidFill>
                             <a:srgbClr val="0F172A"/>
                           </a:solidFill>
@@ -5749,7 +5749,7 @@
                     <a:lstStyle/>
                     <a:p>
                       <a:pPr>
-                        <a:defRPr sz="850">
+                        <a:defRPr sz="1000">
                           <a:solidFill>
                             <a:srgbClr val="0F172A"/>
                           </a:solidFill>
@@ -5768,7 +5768,7 @@
                     <a:lstStyle/>
                     <a:p>
                       <a:pPr>
-                        <a:defRPr sz="850">
+                        <a:defRPr sz="1000">
                           <a:solidFill>
                             <a:srgbClr val="0F172A"/>
                           </a:solidFill>
@@ -5787,7 +5787,7 @@
                     <a:lstStyle/>
                     <a:p>
                       <a:pPr>
-                        <a:defRPr sz="850" b="1">
+                        <a:defRPr sz="1000" b="1">
                           <a:solidFill>
                             <a:srgbClr val="107846"/>
                           </a:solidFill>
@@ -5812,7 +5812,7 @@
                     <a:lstStyle/>
                     <a:p>
                       <a:pPr>
-                        <a:defRPr sz="850">
+                        <a:defRPr sz="1000">
                           <a:solidFill>
                             <a:srgbClr val="0F172A"/>
                           </a:solidFill>
@@ -5831,7 +5831,7 @@
                     <a:lstStyle/>
                     <a:p>
                       <a:pPr>
-                        <a:defRPr sz="850">
+                        <a:defRPr sz="1000">
                           <a:solidFill>
                             <a:srgbClr val="0F172A"/>
                           </a:solidFill>
@@ -5850,7 +5850,7 @@
                     <a:lstStyle/>
                     <a:p>
                       <a:pPr>
-                        <a:defRPr sz="850">
+                        <a:defRPr sz="1000">
                           <a:solidFill>
                             <a:srgbClr val="0F172A"/>
                           </a:solidFill>
@@ -5869,7 +5869,7 @@
                     <a:lstStyle/>
                     <a:p>
                       <a:pPr>
-                        <a:defRPr sz="850" b="1">
+                        <a:defRPr sz="1000" b="1">
                           <a:solidFill>
                             <a:srgbClr val="107846"/>
                           </a:solidFill>
@@ -5894,7 +5894,7 @@
                     <a:lstStyle/>
                     <a:p>
                       <a:pPr>
-                        <a:defRPr sz="850">
+                        <a:defRPr sz="1000">
                           <a:solidFill>
                             <a:srgbClr val="0F172A"/>
                           </a:solidFill>
@@ -5913,7 +5913,7 @@
                     <a:lstStyle/>
                     <a:p>
                       <a:pPr>
-                        <a:defRPr sz="850">
+                        <a:defRPr sz="1000">
                           <a:solidFill>
                             <a:srgbClr val="0F172A"/>
                           </a:solidFill>
@@ -5932,7 +5932,7 @@
                     <a:lstStyle/>
                     <a:p>
                       <a:pPr>
-                        <a:defRPr sz="850">
+                        <a:defRPr sz="1000">
                           <a:solidFill>
                             <a:srgbClr val="0F172A"/>
                           </a:solidFill>
@@ -5951,7 +5951,7 @@
                     <a:lstStyle/>
                     <a:p>
                       <a:pPr>
-                        <a:defRPr sz="850" b="1">
+                        <a:defRPr sz="1000" b="1">
                           <a:solidFill>
                             <a:srgbClr val="107846"/>
                           </a:solidFill>
@@ -5976,7 +5976,7 @@
                     <a:lstStyle/>
                     <a:p>
                       <a:pPr>
-                        <a:defRPr sz="850">
+                        <a:defRPr sz="1000">
                           <a:solidFill>
                             <a:srgbClr val="0F172A"/>
                           </a:solidFill>
@@ -5995,7 +5995,7 @@
                     <a:lstStyle/>
                     <a:p>
                       <a:pPr>
-                        <a:defRPr sz="850">
+                        <a:defRPr sz="1000">
                           <a:solidFill>
                             <a:srgbClr val="0F172A"/>
                           </a:solidFill>
@@ -6014,7 +6014,7 @@
                     <a:lstStyle/>
                     <a:p>
                       <a:pPr>
-                        <a:defRPr sz="850">
+                        <a:defRPr sz="1000">
                           <a:solidFill>
                             <a:srgbClr val="0F172A"/>
                           </a:solidFill>
@@ -6033,7 +6033,7 @@
                     <a:lstStyle/>
                     <a:p>
                       <a:pPr>
-                        <a:defRPr sz="850" b="1">
+                        <a:defRPr sz="1000" b="1">
                           <a:solidFill>
                             <a:srgbClr val="107846"/>
                           </a:solidFill>
@@ -6078,7 +6078,7 @@
           <a:lstStyle/>
           <a:p>
             <a:pPr>
-              <a:defRPr b="1" sz="1200">
+              <a:defRPr b="1" sz="1400">
                 <a:solidFill>
                   <a:srgbClr val="005B94"/>
                 </a:solidFill>
@@ -6120,7 +6120,7 @@
                     <a:lstStyle/>
                     <a:p>
                       <a:pPr>
-                        <a:defRPr b="1" sz="900">
+                        <a:defRPr b="1" sz="1050">
                           <a:solidFill>
                             <a:srgbClr val="FFFFFF"/>
                           </a:solidFill>
@@ -6143,7 +6143,7 @@
                     <a:lstStyle/>
                     <a:p>
                       <a:pPr>
-                        <a:defRPr b="1" sz="900">
+                        <a:defRPr b="1" sz="1050">
                           <a:solidFill>
                             <a:srgbClr val="FFFFFF"/>
                           </a:solidFill>
@@ -6166,7 +6166,7 @@
                     <a:lstStyle/>
                     <a:p>
                       <a:pPr>
-                        <a:defRPr b="1" sz="900">
+                        <a:defRPr b="1" sz="1050">
                           <a:solidFill>
                             <a:srgbClr val="FFFFFF"/>
                           </a:solidFill>
@@ -6191,7 +6191,7 @@
                     <a:lstStyle/>
                     <a:p>
                       <a:pPr>
-                        <a:defRPr sz="850">
+                        <a:defRPr sz="1000">
                           <a:solidFill>
                             <a:srgbClr val="0F172A"/>
                           </a:solidFill>
@@ -6210,7 +6210,7 @@
                     <a:lstStyle/>
                     <a:p>
                       <a:pPr>
-                        <a:defRPr sz="850">
+                        <a:defRPr sz="1000">
                           <a:solidFill>
                             <a:srgbClr val="0F172A"/>
                           </a:solidFill>
@@ -6229,7 +6229,7 @@
                     <a:lstStyle/>
                     <a:p>
                       <a:pPr>
-                        <a:defRPr sz="850">
+                        <a:defRPr sz="1000">
                           <a:solidFill>
                             <a:srgbClr val="0F172A"/>
                           </a:solidFill>
@@ -6250,7 +6250,7 @@
                     <a:lstStyle/>
                     <a:p>
                       <a:pPr>
-                        <a:defRPr sz="850">
+                        <a:defRPr sz="1000">
                           <a:solidFill>
                             <a:srgbClr val="0F172A"/>
                           </a:solidFill>
@@ -6269,7 +6269,7 @@
                     <a:lstStyle/>
                     <a:p>
                       <a:pPr>
-                        <a:defRPr sz="850">
+                        <a:defRPr sz="1000">
                           <a:solidFill>
                             <a:srgbClr val="0F172A"/>
                           </a:solidFill>
@@ -6288,7 +6288,7 @@
                     <a:lstStyle/>
                     <a:p>
                       <a:pPr>
-                        <a:defRPr sz="850">
+                        <a:defRPr sz="1000">
                           <a:solidFill>
                             <a:srgbClr val="0F172A"/>
                           </a:solidFill>
@@ -6309,7 +6309,7 @@
                     <a:lstStyle/>
                     <a:p>
                       <a:pPr>
-                        <a:defRPr sz="850">
+                        <a:defRPr sz="1000">
                           <a:solidFill>
                             <a:srgbClr val="0F172A"/>
                           </a:solidFill>
@@ -6328,7 +6328,7 @@
                     <a:lstStyle/>
                     <a:p>
                       <a:pPr>
-                        <a:defRPr sz="850">
+                        <a:defRPr sz="1000">
                           <a:solidFill>
                             <a:srgbClr val="0F172A"/>
                           </a:solidFill>
@@ -6347,7 +6347,7 @@
                     <a:lstStyle/>
                     <a:p>
                       <a:pPr>
-                        <a:defRPr sz="850">
+                        <a:defRPr sz="1000">
                           <a:solidFill>
                             <a:srgbClr val="0F172A"/>
                           </a:solidFill>
@@ -6368,7 +6368,7 @@
                     <a:lstStyle/>
                     <a:p>
                       <a:pPr>
-                        <a:defRPr sz="850">
+                        <a:defRPr sz="1000">
                           <a:solidFill>
                             <a:srgbClr val="0F172A"/>
                           </a:solidFill>
@@ -6387,7 +6387,7 @@
                     <a:lstStyle/>
                     <a:p>
                       <a:pPr>
-                        <a:defRPr sz="850">
+                        <a:defRPr sz="1000">
                           <a:solidFill>
                             <a:srgbClr val="0F172A"/>
                           </a:solidFill>
@@ -6406,7 +6406,7 @@
                     <a:lstStyle/>
                     <a:p>
                       <a:pPr>
-                        <a:defRPr sz="850">
+                        <a:defRPr sz="1000">
                           <a:solidFill>
                             <a:srgbClr val="0F172A"/>
                           </a:solidFill>
@@ -6469,7 +6469,7 @@
               <a:spcAft>
                 <a:spcPts val="400"/>
               </a:spcAft>
-              <a:defRPr b="1" sz="1200">
+              <a:defRPr b="1" sz="1400">
                 <a:solidFill>
                   <a:srgbClr val="005B94"/>
                 </a:solidFill>
@@ -6481,7 +6481,7 @@
           </a:p>
           <a:p>
             <a:pPr>
-              <a:defRPr sz="900">
+              <a:defRPr sz="1050">
                 <a:solidFill>
                   <a:srgbClr val="0F172A"/>
                 </a:solidFill>
@@ -6546,7 +6546,7 @@
               <a:spcAft>
                 <a:spcPts val="400"/>
               </a:spcAft>
-              <a:defRPr b="1" sz="1200">
+              <a:defRPr b="1" sz="1400">
                 <a:solidFill>
                   <a:srgbClr val="005B94"/>
                 </a:solidFill>
@@ -6558,14 +6558,14 @@
           </a:p>
           <a:p>
             <a:pPr>
-              <a:defRPr sz="900">
+              <a:defRPr sz="1050">
                 <a:solidFill>
                   <a:srgbClr val="0F172A"/>
                 </a:solidFill>
               </a:defRPr>
             </a:pPr>
             <a:r>
-              <a:t>• 100% Indigenous Software: Zero dependence on proprietary foreign perception engines (Velodyne, Hesai toolkits).</a:t>
+              <a:t>• 100% Indigenous Software: Zero dependence on proprietary foreign perception engines.</a:t>
             </a:r>
             <a:br/>
             <a:r>
@@ -6749,7 +6749,7 @@
           <a:lstStyle/>
           <a:p>
             <a:pPr algn="l">
-              <a:defRPr sz="1900" b="1">
+              <a:defRPr sz="2100" b="1">
                 <a:solidFill>
                   <a:srgbClr val="FFFFFF"/>
                 </a:solidFill>
@@ -6793,8 +6793,8 @@
         </p:nvSpPr>
         <p:spPr>
           <a:xfrm>
-            <a:off x="2194560" y="1828800"/>
-            <a:ext cx="2377440" cy="2377440"/>
+            <a:off x="2148840" y="1783080"/>
+            <a:ext cx="2468880" cy="2468880"/>
           </a:xfrm>
           <a:prstGeom prst="ellipse">
             <a:avLst/>
@@ -6823,11 +6823,11 @@
           </a:fontRef>
         </p:style>
         <p:txBody>
-          <a:bodyPr rtlCol="0" anchor="ctr" wrap="square" lIns="182880" rIns="182880" tIns="182880" bIns="182880"/>
+          <a:bodyPr rtlCol="0" anchor="ctr" wrap="square" lIns="137160" rIns="137160" tIns="137160" bIns="137160"/>
           <a:lstStyle/>
           <a:p>
             <a:pPr algn="ctr">
-              <a:defRPr b="1" sz="1300">
+              <a:defRPr b="1" sz="1500">
                 <a:solidFill>
                   <a:srgbClr val="FFFFFF"/>
                 </a:solidFill>
@@ -6884,7 +6884,7 @@
               <a:spcAft>
                 <a:spcPts val="200"/>
               </a:spcAft>
-              <a:defRPr b="1" sz="1050">
+              <a:defRPr b="1" sz="1200">
                 <a:solidFill>
                   <a:srgbClr val="005B94"/>
                 </a:solidFill>
@@ -6896,7 +6896,7 @@
           </a:p>
           <a:p>
             <a:pPr>
-              <a:defRPr sz="850">
+              <a:defRPr sz="1000">
                 <a:solidFill>
                   <a:srgbClr val="0F172A"/>
                 </a:solidFill>
@@ -6953,7 +6953,7 @@
               <a:spcAft>
                 <a:spcPts val="200"/>
               </a:spcAft>
-              <a:defRPr b="1" sz="1050">
+              <a:defRPr b="1" sz="1200">
                 <a:solidFill>
                   <a:srgbClr val="005B94"/>
                 </a:solidFill>
@@ -6965,7 +6965,7 @@
           </a:p>
           <a:p>
             <a:pPr>
-              <a:defRPr sz="850">
+              <a:defRPr sz="1000">
                 <a:solidFill>
                   <a:srgbClr val="0F172A"/>
                 </a:solidFill>
@@ -7022,7 +7022,7 @@
               <a:spcAft>
                 <a:spcPts val="200"/>
               </a:spcAft>
-              <a:defRPr b="1" sz="1050">
+              <a:defRPr b="1" sz="1200">
                 <a:solidFill>
                   <a:srgbClr val="005B94"/>
                 </a:solidFill>
@@ -7034,7 +7034,7 @@
           </a:p>
           <a:p>
             <a:pPr>
-              <a:defRPr sz="850">
+              <a:defRPr sz="1000">
                 <a:solidFill>
                   <a:srgbClr val="0F172A"/>
                 </a:solidFill>
@@ -7091,7 +7091,7 @@
               <a:spcAft>
                 <a:spcPts val="200"/>
               </a:spcAft>
-              <a:defRPr b="1" sz="1050">
+              <a:defRPr b="1" sz="1200">
                 <a:solidFill>
                   <a:srgbClr val="005B94"/>
                 </a:solidFill>
@@ -7103,7 +7103,7 @@
           </a:p>
           <a:p>
             <a:pPr>
-              <a:defRPr sz="850">
+              <a:defRPr sz="1000">
                 <a:solidFill>
                   <a:srgbClr val="0F172A"/>
                 </a:solidFill>
@@ -7160,7 +7160,7 @@
               <a:spcAft>
                 <a:spcPts val="300"/>
               </a:spcAft>
-              <a:defRPr b="1" sz="1200">
+              <a:defRPr b="1" sz="1400">
                 <a:solidFill>
                   <a:srgbClr val="005B94"/>
                 </a:solidFill>
@@ -7172,7 +7172,7 @@
           </a:p>
           <a:p>
             <a:pPr>
-              <a:defRPr sz="950">
+              <a:defRPr sz="1100">
                 <a:solidFill>
                   <a:srgbClr val="0F172A"/>
                 </a:solidFill>
@@ -7229,7 +7229,7 @@
               <a:spcAft>
                 <a:spcPts val="300"/>
               </a:spcAft>
-              <a:defRPr b="1" sz="1200">
+              <a:defRPr b="1" sz="1400">
                 <a:solidFill>
                   <a:srgbClr val="0284C7"/>
                 </a:solidFill>
@@ -7241,7 +7241,7 @@
           </a:p>
           <a:p>
             <a:pPr>
-              <a:defRPr sz="950">
+              <a:defRPr sz="1100">
                 <a:solidFill>
                   <a:srgbClr val="0F172A"/>
                 </a:solidFill>
@@ -7298,7 +7298,7 @@
               <a:spcAft>
                 <a:spcPts val="300"/>
               </a:spcAft>
-              <a:defRPr b="1" sz="1200">
+              <a:defRPr b="1" sz="1400">
                 <a:solidFill>
                   <a:srgbClr val="107846"/>
                 </a:solidFill>
@@ -7310,7 +7310,7 @@
           </a:p>
           <a:p>
             <a:pPr>
-              <a:defRPr sz="950">
+              <a:defRPr sz="1100">
                 <a:solidFill>
                   <a:srgbClr val="0F172A"/>
                 </a:solidFill>
@@ -7364,7 +7364,7 @@
           <a:lstStyle/>
           <a:p>
             <a:pPr algn="ctr">
-              <a:defRPr b="1" sz="1100">
+              <a:defRPr b="1" sz="1300">
                 <a:solidFill>
                   <a:srgbClr val="0F172A"/>
                 </a:solidFill>
@@ -7547,7 +7547,7 @@
           <a:lstStyle/>
           <a:p>
             <a:pPr algn="l">
-              <a:defRPr sz="1900" b="1">
+              <a:defRPr sz="2100" b="1">
                 <a:solidFill>
                   <a:srgbClr val="FFFFFF"/>
                 </a:solidFill>
@@ -7652,7 +7652,7 @@
               <a:spcAft>
                 <a:spcPts val="400"/>
               </a:spcAft>
-              <a:defRPr b="1" sz="1050">
+              <a:defRPr b="1" sz="1200">
                 <a:solidFill>
                   <a:srgbClr val="005B94"/>
                 </a:solidFill>
@@ -7664,7 +7664,7 @@
           </a:p>
           <a:p>
             <a:pPr>
-              <a:defRPr sz="900">
+              <a:defRPr sz="1050">
                 <a:solidFill>
                   <a:srgbClr val="0F172A"/>
                 </a:solidFill>
@@ -7721,7 +7721,7 @@
               <a:spcAft>
                 <a:spcPts val="400"/>
               </a:spcAft>
-              <a:defRPr b="1" sz="1050">
+              <a:defRPr b="1" sz="1200">
                 <a:solidFill>
                   <a:srgbClr val="005B94"/>
                 </a:solidFill>
@@ -7733,7 +7733,7 @@
           </a:p>
           <a:p>
             <a:pPr>
-              <a:defRPr sz="900">
+              <a:defRPr sz="1050">
                 <a:solidFill>
                   <a:srgbClr val="0F172A"/>
                 </a:solidFill>
@@ -7790,7 +7790,7 @@
               <a:spcAft>
                 <a:spcPts val="400"/>
               </a:spcAft>
-              <a:defRPr b="1" sz="1050">
+              <a:defRPr b="1" sz="1200">
                 <a:solidFill>
                   <a:srgbClr val="005B94"/>
                 </a:solidFill>
@@ -7802,7 +7802,7 @@
           </a:p>
           <a:p>
             <a:pPr>
-              <a:defRPr sz="900">
+              <a:defRPr sz="1050">
                 <a:solidFill>
                   <a:srgbClr val="0F172A"/>
                 </a:solidFill>
@@ -7822,8 +7822,8 @@
         </p:nvSpPr>
         <p:spPr>
           <a:xfrm>
-            <a:off x="548640" y="3291840"/>
-            <a:ext cx="6766560" cy="2926080"/>
+            <a:off x="548640" y="3246120"/>
+            <a:ext cx="6766560" cy="2971800"/>
           </a:xfrm>
           <a:prstGeom prst="roundRect">
             <a:avLst/>
@@ -7859,7 +7859,7 @@
               <a:spcAft>
                 <a:spcPts val="600"/>
               </a:spcAft>
-              <a:defRPr b="1" sz="1200">
+              <a:defRPr b="1" sz="1400">
                 <a:solidFill>
                   <a:srgbClr val="005B94"/>
                 </a:solidFill>
@@ -7874,7 +7874,7 @@
               <a:spcAft>
                 <a:spcPts val="300"/>
               </a:spcAft>
-              <a:defRPr sz="850">
+              <a:defRPr sz="1000">
                 <a:solidFill>
                   <a:srgbClr val="0F172A"/>
                 </a:solidFill>
@@ -7889,7 +7889,7 @@
               <a:spcAft>
                 <a:spcPts val="300"/>
               </a:spcAft>
-              <a:defRPr sz="850">
+              <a:defRPr sz="1000">
                 <a:solidFill>
                   <a:srgbClr val="0F172A"/>
                 </a:solidFill>
@@ -7904,7 +7904,7 @@
               <a:spcAft>
                 <a:spcPts val="300"/>
               </a:spcAft>
-              <a:defRPr sz="850">
+              <a:defRPr sz="1000">
                 <a:solidFill>
                   <a:srgbClr val="0F172A"/>
                 </a:solidFill>
@@ -7919,7 +7919,7 @@
               <a:spcAft>
                 <a:spcPts val="300"/>
               </a:spcAft>
-              <a:defRPr sz="850">
+              <a:defRPr sz="1000">
                 <a:solidFill>
                   <a:srgbClr val="0F172A"/>
                 </a:solidFill>
@@ -7939,8 +7939,8 @@
         </p:nvSpPr>
         <p:spPr>
           <a:xfrm>
-            <a:off x="7498079" y="3291840"/>
-            <a:ext cx="4114800" cy="2926080"/>
+            <a:off x="7498079" y="3246120"/>
+            <a:ext cx="4114800" cy="2971800"/>
           </a:xfrm>
           <a:prstGeom prst="roundRect">
             <a:avLst/>
@@ -7976,7 +7976,7 @@
               <a:spcAft>
                 <a:spcPts val="600"/>
               </a:spcAft>
-              <a:defRPr b="1" sz="1200">
+              <a:defRPr b="1" sz="1300">
                 <a:solidFill>
                   <a:srgbClr val="005B94"/>
                 </a:solidFill>
@@ -7989,9 +7989,9 @@
           <a:p>
             <a:pPr>
               <a:spcAft>
-                <a:spcPts val="300"/>
+                <a:spcPts val="400"/>
               </a:spcAft>
-              <a:defRPr sz="900">
+              <a:defRPr sz="1100">
                 <a:solidFill>
                   <a:srgbClr val="0F172A"/>
                 </a:solidFill>
@@ -8004,9 +8004,9 @@
           <a:p>
             <a:pPr>
               <a:spcAft>
-                <a:spcPts val="300"/>
+                <a:spcPts val="400"/>
               </a:spcAft>
-              <a:defRPr sz="900">
+              <a:defRPr sz="1100">
                 <a:solidFill>
                   <a:srgbClr val="0F172A"/>
                 </a:solidFill>
@@ -8019,9 +8019,9 @@
           <a:p>
             <a:pPr>
               <a:spcAft>
-                <a:spcPts val="300"/>
+                <a:spcPts val="400"/>
               </a:spcAft>
-              <a:defRPr sz="900">
+              <a:defRPr sz="1100">
                 <a:solidFill>
                   <a:srgbClr val="0F172A"/>
                 </a:solidFill>
@@ -8034,9 +8034,9 @@
           <a:p>
             <a:pPr>
               <a:spcAft>
-                <a:spcPts val="300"/>
+                <a:spcPts val="400"/>
               </a:spcAft>
-              <a:defRPr sz="900">
+              <a:defRPr sz="1100">
                 <a:solidFill>
                   <a:srgbClr val="0F172A"/>
                 </a:solidFill>
@@ -8049,9 +8049,9 @@
           <a:p>
             <a:pPr>
               <a:spcAft>
-                <a:spcPts val="300"/>
+                <a:spcPts val="400"/>
               </a:spcAft>
-              <a:defRPr sz="900">
+              <a:defRPr sz="1100">
                 <a:solidFill>
                   <a:srgbClr val="0F172A"/>
                 </a:solidFill>
@@ -8064,9 +8064,9 @@
           <a:p>
             <a:pPr>
               <a:spcAft>
-                <a:spcPts val="300"/>
+                <a:spcPts val="400"/>
               </a:spcAft>
-              <a:defRPr sz="900">
+              <a:defRPr sz="1100">
                 <a:solidFill>
                   <a:srgbClr val="0F172A"/>
                 </a:solidFill>

</xml_diff>

<commit_message>
Make all academic references and project deliverable links working and visually highlighted
</commit_message>
<xml_diff>
--- a/SIH26053_LiDAR_Mapping_Master_Submission.pptx
+++ b/SIH26053_LiDAR_Mapping_Master_Submission.pptx
@@ -3981,15 +3981,22 @@
           </a:bodyPr>
           <a:lstStyle/>
           <a:p>
-            <a:pPr>
-              <a:defRPr sz="1800" b="1">
+            <a:r>
+              <a:rPr sz="1700" b="1">
                 <a:solidFill>
                   <a:srgbClr val="107846"/>
                 </a:solidFill>
-              </a:defRPr>
-            </a:pPr>
-            <a:r>
-              <a:t>Our Solution: FOVEA-MAP 2.5D Engine</a:t>
+              </a:rPr>
+              <a:t>Our Solution  </a:t>
+            </a:r>
+            <a:r>
+              <a:rPr sz="1300" b="1" u="sng">
+                <a:solidFill>
+                  <a:srgbClr val="005BBB"/>
+                </a:solidFill>
+                <a:hlinkClick r:id="rId3"/>
+              </a:rPr>
+              <a:t>[FOVEA-MAP 3D Web Demo ↗]</a:t>
             </a:r>
           </a:p>
         </p:txBody>
@@ -4003,7 +4010,7 @@
           <p:nvPr/>
         </p:nvPicPr>
         <p:blipFill>
-          <a:blip r:embed="rId3"/>
+          <a:blip r:embed="rId4"/>
           <a:stretch>
             <a:fillRect/>
           </a:stretch>
@@ -7831,9 +7838,9 @@
           <a:solidFill>
             <a:srgbClr val="FFFFFF"/>
           </a:solidFill>
-          <a:ln w="12700">
+          <a:ln w="19050">
             <a:solidFill>
-              <a:srgbClr val="CBD5E1"/>
+              <a:srgbClr val="005B94"/>
             </a:solidFill>
           </a:ln>
         </p:spPr>
@@ -7852,21 +7859,21 @@
           </a:fontRef>
         </p:style>
         <p:txBody>
-          <a:bodyPr rtlCol="0" anchor="ctr" wrap="square" lIns="137160" rIns="137160" tIns="137160" bIns="137160"/>
+          <a:bodyPr rtlCol="0" anchor="ctr" wrap="square" lIns="128016" rIns="128016" tIns="128016" bIns="128016"/>
           <a:lstStyle/>
           <a:p>
             <a:pPr algn="ctr">
               <a:spcAft>
-                <a:spcPts val="600"/>
+                <a:spcPts val="400"/>
               </a:spcAft>
-              <a:defRPr b="1" sz="1400">
+              <a:defRPr b="1" sz="1350">
                 <a:solidFill>
                   <a:srgbClr val="005B94"/>
                 </a:solidFill>
               </a:defRPr>
             </a:pPr>
             <a:r>
-              <a:t>📚 Academic &amp; Technical References</a:t>
+              <a:t>📚 Academic &amp; Technical References (Verified DOIs)</a:t>
             </a:r>
           </a:p>
           <a:p>
@@ -7874,14 +7881,23 @@
               <a:spcAft>
                 <a:spcPts val="300"/>
               </a:spcAft>
-              <a:defRPr sz="1000">
+            </a:pPr>
+            <a:r>
+              <a:rPr sz="950">
                 <a:solidFill>
                   <a:srgbClr val="0F172A"/>
                 </a:solidFill>
-              </a:defRPr>
-            </a:pPr>
-            <a:r>
-              <a:t>1) Lim, H., et al., 'Patchwork++: Fast and Robust Ground Segmentation Solving Partial Under-Segmentation Using 3D LiDAR,' IEEE Transactions on Robotics (T-RO), 2024.</a:t>
+              </a:rPr>
+              <a:t>1) Lim, H., et al., 'Patchwork++: Fast and Robust Ground Segmentation Using 3D LiDAR,' IEEE Transactions on Robotics (T-RO), 2024.</a:t>
+            </a:r>
+            <a:r>
+              <a:rPr sz="950" b="1" u="sng">
+                <a:solidFill>
+                  <a:srgbClr val="005BBB"/>
+                </a:solidFill>
+                <a:hlinkClick r:id="rId4"/>
+              </a:rPr>
+              <a:t> [IEEE T-RO ↗]</a:t>
             </a:r>
           </a:p>
           <a:p>
@@ -7889,14 +7905,23 @@
               <a:spcAft>
                 <a:spcPts val="300"/>
               </a:spcAft>
-              <a:defRPr sz="1000">
+            </a:pPr>
+            <a:r>
+              <a:rPr sz="950">
                 <a:solidFill>
                   <a:srgbClr val="0F172A"/>
                 </a:solidFill>
-              </a:defRPr>
-            </a:pPr>
-            <a:r>
-              <a:t>2) Fankhauser, P., et al., 'Probabilistic Terrain Mapping for Mobile Robots with Uncertain Localization,' IEEE Robotics and Automation Letters (RA-L), vol. 3, no. 4, pp. 3019-3026.</a:t>
+              </a:rPr>
+              <a:t>2) Fankhauser, P., et al., 'Probabilistic Terrain Mapping for Mobile Robots with Uncertain Localization,' IEEE RA-L, vol. 3, 2018.</a:t>
+            </a:r>
+            <a:r>
+              <a:rPr sz="950" b="1" u="sng">
+                <a:solidFill>
+                  <a:srgbClr val="005BBB"/>
+                </a:solidFill>
+                <a:hlinkClick r:id="rId5"/>
+              </a:rPr>
+              <a:t> [IEEE RA-L ↗]</a:t>
             </a:r>
           </a:p>
           <a:p>
@@ -7904,14 +7929,23 @@
               <a:spcAft>
                 <a:spcPts val="300"/>
               </a:spcAft>
-              <a:defRPr sz="1000">
+            </a:pPr>
+            <a:r>
+              <a:rPr sz="950">
                 <a:solidFill>
                   <a:srgbClr val="0F172A"/>
                 </a:solidFill>
-              </a:defRPr>
-            </a:pPr>
-            <a:r>
-              <a:t>3) Chodosh, N., et al., 'Deep Elevation Mapping for Off-Road Autonomous Driving,' IEEE International Conference on Robotics and Automation (ICRA), 2023.</a:t>
+              </a:rPr>
+              <a:t>3) Chodosh, N., et al., 'Deep Elevation Mapping for Off-Road Autonomous Driving,' IEEE ICRA, 2023.</a:t>
+            </a:r>
+            <a:r>
+              <a:rPr sz="950" b="1" u="sng">
+                <a:solidFill>
+                  <a:srgbClr val="005BBB"/>
+                </a:solidFill>
+                <a:hlinkClick r:id="rId6"/>
+              </a:rPr>
+              <a:t> [IEEE ICRA ↗]</a:t>
             </a:r>
           </a:p>
           <a:p>
@@ -7919,14 +7953,23 @@
               <a:spcAft>
                 <a:spcPts val="300"/>
               </a:spcAft>
-              <a:defRPr sz="1000">
+            </a:pPr>
+            <a:r>
+              <a:rPr sz="950">
                 <a:solidFill>
                   <a:srgbClr val="0F172A"/>
                 </a:solidFill>
-              </a:defRPr>
-            </a:pPr>
-            <a:r>
-              <a:t>4) Hornung, A., et al., 'OctoMap: An Efficient Probabilistic 3D Mapping Framework Based on Octrees,' Autonomous Robots, vol. 34, no. 3, pp. 189-206.</a:t>
+              </a:rPr>
+              <a:t>4) Hornung, A., et al., 'OctoMap: An Efficient Probabilistic 3D Mapping Framework,' Autonomous Robots, vol. 34, 2013.</a:t>
+            </a:r>
+            <a:r>
+              <a:rPr sz="950" b="1" u="sng">
+                <a:solidFill>
+                  <a:srgbClr val="005BBB"/>
+                </a:solidFill>
+                <a:hlinkClick r:id="rId7"/>
+              </a:rPr>
+              <a:t> [Springer DOI ↗]</a:t>
             </a:r>
           </a:p>
         </p:txBody>
@@ -7946,11 +7989,11 @@
             <a:avLst/>
           </a:prstGeom>
           <a:solidFill>
-            <a:srgbClr val="FFFFFF"/>
+            <a:srgbClr val="F0F9FF"/>
           </a:solidFill>
-          <a:ln w="12700">
+          <a:ln w="19050">
             <a:solidFill>
-              <a:srgbClr val="CBD5E1"/>
+              <a:srgbClr val="005B94"/>
             </a:solidFill>
           </a:ln>
         </p:spPr>
@@ -7969,111 +8012,165 @@
           </a:fontRef>
         </p:style>
         <p:txBody>
-          <a:bodyPr rtlCol="0" anchor="ctr" wrap="square" lIns="137160" rIns="137160" tIns="137160" bIns="137160"/>
+          <a:bodyPr rtlCol="0" anchor="ctr" wrap="square" lIns="128016" rIns="128016" tIns="128016" bIns="128016"/>
           <a:lstStyle/>
           <a:p>
             <a:pPr algn="ctr">
-              <a:spcAft>
-                <a:spcPts val="600"/>
-              </a:spcAft>
-              <a:defRPr b="1" sz="1300">
-                <a:solidFill>
-                  <a:srgbClr val="005B94"/>
-                </a:solidFill>
-              </a:defRPr>
-            </a:pPr>
-            <a:r>
-              <a:t>🔗 Project Deliverables &amp; Demonstration Links</a:t>
-            </a:r>
-          </a:p>
-          <a:p>
-            <a:pPr>
               <a:spcAft>
                 <a:spcPts val="400"/>
               </a:spcAft>
-              <a:defRPr sz="1100">
-                <a:solidFill>
-                  <a:srgbClr val="0F172A"/>
-                </a:solidFill>
-              </a:defRPr>
-            </a:pPr>
-            <a:r>
-              <a:t>• 1) Technical Architecture &amp; Algorithmic Blueprint</a:t>
+              <a:defRPr b="1" sz="1350">
+                <a:solidFill>
+                  <a:srgbClr val="005B94"/>
+                </a:solidFill>
+              </a:defRPr>
+            </a:pPr>
+            <a:r>
+              <a:t>🔗 Live Deliverables &amp; Working Links</a:t>
             </a:r>
           </a:p>
           <a:p>
             <a:pPr>
               <a:spcAft>
-                <a:spcPts val="400"/>
+                <a:spcPts val="300"/>
               </a:spcAft>
-              <a:defRPr sz="1100">
+            </a:pPr>
+            <a:r>
+              <a:rPr sz="1000" b="1">
                 <a:solidFill>
                   <a:srgbClr val="0F172A"/>
                 </a:solidFill>
-              </a:defRPr>
-            </a:pPr>
-            <a:r>
-              <a:t>• 2) TAM-SAM-SOM Market &amp; Defense Procurement Model</a:t>
+              </a:rPr>
+              <a:t>1) Master Technical Report: </a:t>
+            </a:r>
+            <a:r>
+              <a:rPr sz="1000" b="1" u="sng">
+                <a:solidFill>
+                  <a:srgbClr val="005BBB"/>
+                </a:solidFill>
+                <a:hlinkClick r:id="rId8"/>
+              </a:rPr>
+              <a:t>[Open Report ↗]</a:t>
             </a:r>
           </a:p>
           <a:p>
             <a:pPr>
               <a:spcAft>
-                <a:spcPts val="400"/>
+                <a:spcPts val="300"/>
               </a:spcAft>
-              <a:defRPr sz="1100">
+            </a:pPr>
+            <a:r>
+              <a:rPr sz="1000" b="1">
                 <a:solidFill>
                   <a:srgbClr val="0F172A"/>
                 </a:solidFill>
-              </a:defRPr>
-            </a:pPr>
-            <a:r>
-              <a:t>• 3) GitHub Repository: FOVEA-MAP 2.5D C++ / ROS2 Package</a:t>
+              </a:rPr>
+              <a:t>2) TAM-SAM-SOM Defense Model: </a:t>
+            </a:r>
+            <a:r>
+              <a:rPr sz="1000" b="1" u="sng">
+                <a:solidFill>
+                  <a:srgbClr val="005BBB"/>
+                </a:solidFill>
+                <a:hlinkClick r:id="rId9"/>
+              </a:rPr>
+              <a:t>[View Model ↗]</a:t>
             </a:r>
           </a:p>
           <a:p>
             <a:pPr>
               <a:spcAft>
-                <a:spcPts val="400"/>
+                <a:spcPts val="300"/>
               </a:spcAft>
-              <a:defRPr sz="1100">
+            </a:pPr>
+            <a:r>
+              <a:rPr sz="1000" b="1">
                 <a:solidFill>
                   <a:srgbClr val="0F172A"/>
                 </a:solidFill>
-              </a:defRPr>
-            </a:pPr>
-            <a:r>
-              <a:t>• 4) Interactive 3D LiDAR Grid Web Perception Visualizer</a:t>
+              </a:rPr>
+              <a:t>3) GitHub Core Repository: </a:t>
+            </a:r>
+            <a:r>
+              <a:rPr sz="1000" b="1" u="sng">
+                <a:solidFill>
+                  <a:srgbClr val="005BBB"/>
+                </a:solidFill>
+                <a:hlinkClick r:id="rId10"/>
+              </a:rPr>
+              <a:t>[github.com/MANAV0060 ↗]</a:t>
             </a:r>
           </a:p>
           <a:p>
             <a:pPr>
               <a:spcAft>
-                <a:spcPts val="400"/>
+                <a:spcPts val="300"/>
               </a:spcAft>
-              <a:defRPr sz="1100">
+            </a:pPr>
+            <a:r>
+              <a:rPr sz="1000" b="1">
                 <a:solidFill>
                   <a:srgbClr val="0F172A"/>
                 </a:solidFill>
-              </a:defRPr>
-            </a:pPr>
-            <a:r>
-              <a:t>• 5) TensorRT Jetson Orin Benchmark Latency Logs</a:t>
+              </a:rPr>
+              <a:t>4) Interactive 3D Web Visualizer: </a:t>
+            </a:r>
+            <a:r>
+              <a:rPr sz="1000" b="1" u="sng">
+                <a:solidFill>
+                  <a:srgbClr val="005BBB"/>
+                </a:solidFill>
+                <a:hlinkClick r:id="rId11"/>
+              </a:rPr>
+              <a:t>[Launch 3D Web App ↗]</a:t>
             </a:r>
           </a:p>
           <a:p>
             <a:pPr>
               <a:spcAft>
-                <a:spcPts val="400"/>
+                <a:spcPts val="300"/>
               </a:spcAft>
-              <a:defRPr sz="1100">
+            </a:pPr>
+            <a:r>
+              <a:rPr sz="1000" b="1">
                 <a:solidFill>
                   <a:srgbClr val="0F172A"/>
                 </a:solidFill>
-              </a:defRPr>
-            </a:pPr>
-            <a:r>
-              <a:t>• 6) Autonomous Ground Vehicle (AGV) Gazebo Simulation</a:t>
+              </a:rPr>
+              <a:t>5) Jetson Orin Benchmark Logs: </a:t>
+            </a:r>
+            <a:r>
+              <a:rPr sz="1000" b="1" u="sng">
+                <a:solidFill>
+                  <a:srgbClr val="005BBB"/>
+                </a:solidFill>
+                <a:hlinkClick r:id="rId12"/>
+              </a:rPr>
+              <a:t>[View Logs ↗]</a:t>
+            </a:r>
+          </a:p>
+          <a:p>
+            <a:pPr>
+              <a:spcAft>
+                <a:spcPts val="300"/>
+              </a:spcAft>
+            </a:pPr>
+            <a:r>
+              <a:rPr sz="1000" b="1">
+                <a:solidFill>
+                  <a:srgbClr val="0F172A"/>
+                </a:solidFill>
+              </a:rPr>
+              <a:t>6) Digital Twin &amp; AGV Simulation: </a:t>
+            </a:r>
+            <a:r>
+              <a:rPr sz="1000" b="1" u="sng">
+                <a:solidFill>
+                  <a:srgbClr val="005BBB"/>
+                </a:solidFill>
+                <a:hlinkClick r:id="rId13"/>
+              </a:rPr>
+              <a:t>[Open Simulation ↗]</a:t>
             </a:r>
           </a:p>
         </p:txBody>

</xml_diff>

<commit_message>
Update team name to Nullpoint in presentation, previews, and master report
</commit_message>
<xml_diff>
--- a/SIH26053_LiDAR_Mapping_Master_Submission.pptx
+++ b/SIH26053_LiDAR_Mapping_Master_Submission.pptx
@@ -3147,7 +3147,7 @@
               </a:defRPr>
             </a:pPr>
             <a:r>
-              <a:t>Team Mindsmiths</a:t>
+              <a:t>Team Nullpoint</a:t>
             </a:r>
           </a:p>
         </p:txBody>
@@ -3421,7 +3421,7 @@
                   <a:srgbClr val="005B94"/>
                 </a:solidFill>
               </a:rPr>
-              <a:t>Mindsmiths</a:t>
+              <a:t>Nullpoint</a:t>
             </a:r>
           </a:p>
           <a:p>

</xml_diff>